<commit_message>
feat(ui): reusable liquid-glass components across the web app
Replace raw .glass/.glass-pill classes with shared Glass and GlassPill
components (SVG displacement refraction), document Rule W-35, and tighten
RDF SHACL conformance checks.

Co-authored-by: Cursor <cursoragent@cursor.com>
</commit_message>
<xml_diff>
--- a/storytelling_presentation_10min.pptx
+++ b/storytelling_presentation_10min.pptx
@@ -507,13 +507,37 @@
           <a:bodyPr/>
           <a:lstStyle/>
           <a:p>
-            <a:r>
-              <a:rPr lang="en-US" dirty="0"/>
-              <a:t>אני פותח בשאלה: למה הרבה מצגות אקדמיות מרגישות כמו רשימת עובדות ולא כמו סיפור?
-המטרה של המצגת היא להראות איך אפשר להפוך תוכן אקדמי למשהו הרבה יותר ברור, חי ומעניין, בלי לוותר על הדיוק.
-אני לא מתחיל בפרטים הטכניים. אני מתחיל במסגרת שמחזיקה את כל המצגת.</a:t>
-            </a:r>
-            <a:endParaRPr lang="en-US" dirty="0"/>
+            <a:pPr rtl="1" algn="r"/>
+            <a:r>
+              <a:rPr lang="he-IL" dirty="0">
+                <a:cs typeface="Arial"/>
+                <a:ea typeface="Arial"/>
+              </a:rPr>
+              <a:t>אני פותח בשאלה: למה הרבה מצגות אקדמיות מרגישות כמו רשימת עובדות ולא כמו סיפור?</a:t>
+            </a:r>
+            <a:endParaRPr lang="he-IL" dirty="0"/>
+          </a:p>
+          <a:p>
+            <a:pPr rtl="1" algn="r"/>
+            <a:r>
+              <a:rPr lang="he-IL" dirty="0">
+                <a:cs typeface="Arial"/>
+                <a:ea typeface="Arial"/>
+              </a:rPr>
+              <a:t>המטרה של המצגת היא להראות איך אפשר להפוך תוכן אקדמי למשהו הרבה יותר ברור, חי ומעניין, בלי לוותר על הדיוק.</a:t>
+            </a:r>
+            <a:endParaRPr lang="he-IL" dirty="0"/>
+          </a:p>
+          <a:p>
+            <a:pPr rtl="1" algn="r"/>
+            <a:r>
+              <a:rPr lang="he-IL" dirty="0">
+                <a:cs typeface="Arial"/>
+                <a:ea typeface="Arial"/>
+              </a:rPr>
+              <a:t>אני לא מתחיל בפרטים הטכניים. אני מתחיל במסגרת שמחזיקה את כל המצגת.</a:t>
+            </a:r>
+            <a:endParaRPr lang="he-IL" dirty="0"/>
           </a:p>
         </p:txBody>
       </p:sp>
@@ -597,13 +621,37 @@
           <a:bodyPr/>
           <a:lstStyle/>
           <a:p>
-            <a:r>
-              <a:rPr lang="en-US" dirty="0"/>
-              <a:t>השלד הכי חשוב הוא And, But, Therefore.
-קודם נותנים קונטקסט, אחר כך מציגים את הפער או המתח, ורק אז את הפתרון.
-זה מונע מצגת כרונולוגית של "ואז, ואז, ואז", ומכריח אותי לבנות טיעון.</a:t>
-            </a:r>
-            <a:endParaRPr lang="en-US" dirty="0"/>
+            <a:pPr rtl="1" algn="r"/>
+            <a:r>
+              <a:rPr lang="he-IL" dirty="0">
+                <a:cs typeface="Arial"/>
+                <a:ea typeface="Arial"/>
+              </a:rPr>
+              <a:t>השלד הכי חשוב הוא And, But, Therefore.</a:t>
+            </a:r>
+            <a:endParaRPr lang="he-IL" dirty="0"/>
+          </a:p>
+          <a:p>
+            <a:pPr rtl="1" algn="r"/>
+            <a:r>
+              <a:rPr lang="he-IL" dirty="0">
+                <a:cs typeface="Arial"/>
+                <a:ea typeface="Arial"/>
+              </a:rPr>
+              <a:t>קודם נותנים קונטקסט, אחר כך מציגים את הפער או המתח, ורק אז את הפתרון.</a:t>
+            </a:r>
+            <a:endParaRPr lang="he-IL" dirty="0"/>
+          </a:p>
+          <a:p>
+            <a:pPr rtl="1" algn="r"/>
+            <a:r>
+              <a:rPr lang="he-IL" dirty="0">
+                <a:cs typeface="Arial"/>
+                <a:ea typeface="Arial"/>
+              </a:rPr>
+              <a:t>זה מונע מצגת כרונולוגית של &amp;quot;ואז, ואז, ואז&amp;quot;, ומכריח אותי לבנות טיעון.</a:t>
+            </a:r>
+            <a:endParaRPr lang="he-IL" dirty="0"/>
           </a:p>
         </p:txBody>
       </p:sp>
@@ -687,13 +735,37 @@
           <a:bodyPr/>
           <a:lstStyle/>
           <a:p>
-            <a:r>
-              <a:rPr lang="en-US" dirty="0"/>
-              <a:t>בדקה הראשונה אני לא מציג את עצמי בצורה ארוכה, אלא פותח עם שאלה, עובדה מפתיעה או דימוי שמכניס את הקהל ישר פנימה.
-אם הקהל לא נכנס כבר בהתחלה, קשה מאוד להחזיר את תשומת הלב שלו אחר כך.
-כאן אני רוצה להראות שהפתיחה היא לא הקדמה טכנית, אלא חלק מהסיפור.</a:t>
-            </a:r>
-            <a:endParaRPr lang="en-US" dirty="0"/>
+            <a:pPr rtl="1" algn="r"/>
+            <a:r>
+              <a:rPr lang="he-IL" dirty="0">
+                <a:cs typeface="Arial"/>
+                <a:ea typeface="Arial"/>
+              </a:rPr>
+              <a:t>בדקה הראשונה אני לא מציג את עצמי בצורה ארוכה, אלא פותח עם שאלה, עובדה מפתיעה או דימוי שמכניס את הקהל ישר פנימה.</a:t>
+            </a:r>
+            <a:endParaRPr lang="he-IL" dirty="0"/>
+          </a:p>
+          <a:p>
+            <a:pPr rtl="1" algn="r"/>
+            <a:r>
+              <a:rPr lang="he-IL" dirty="0">
+                <a:cs typeface="Arial"/>
+                <a:ea typeface="Arial"/>
+              </a:rPr>
+              <a:t>אם הקהל לא נכנס כבר בהתחלה, קשה מאוד להחזיר את תשומת הלב שלו אחר כך.</a:t>
+            </a:r>
+            <a:endParaRPr lang="he-IL" dirty="0"/>
+          </a:p>
+          <a:p>
+            <a:pPr rtl="1" algn="r"/>
+            <a:r>
+              <a:rPr lang="he-IL" dirty="0">
+                <a:cs typeface="Arial"/>
+                <a:ea typeface="Arial"/>
+              </a:rPr>
+              <a:t>כאן אני רוצה להראות שהפתיחה היא לא הקדמה טכנית, אלא חלק מהסיפור.</a:t>
+            </a:r>
+            <a:endParaRPr lang="he-IL" dirty="0"/>
           </a:p>
         </p:txBody>
       </p:sp>
@@ -777,13 +849,37 @@
           <a:bodyPr/>
           <a:lstStyle/>
           <a:p>
-            <a:r>
-              <a:rPr lang="en-US" dirty="0"/>
-              <a:t>כל שקף צריך לשרת רעיון אחד.
-הכותרת עצמה צריכה להגיד את המסקנה, ולא רק להיות שם של נושא.
-אם יש יותר מדי טקסט, הקהל מתחיל לקרוא במקום להקשיב.</a:t>
-            </a:r>
-            <a:endParaRPr lang="en-US" dirty="0"/>
+            <a:pPr rtl="1" algn="r"/>
+            <a:r>
+              <a:rPr lang="he-IL" dirty="0">
+                <a:cs typeface="Arial"/>
+                <a:ea typeface="Arial"/>
+              </a:rPr>
+              <a:t>כל שקף צריך לשרת רעיון אחד.</a:t>
+            </a:r>
+            <a:endParaRPr lang="he-IL" dirty="0"/>
+          </a:p>
+          <a:p>
+            <a:pPr rtl="1" algn="r"/>
+            <a:r>
+              <a:rPr lang="he-IL" dirty="0">
+                <a:cs typeface="Arial"/>
+                <a:ea typeface="Arial"/>
+              </a:rPr>
+              <a:t>הכותרת עצמה צריכה להגיד את המסקנה, ולא רק להיות שם של נושא.</a:t>
+            </a:r>
+            <a:endParaRPr lang="he-IL" dirty="0"/>
+          </a:p>
+          <a:p>
+            <a:pPr rtl="1" algn="r"/>
+            <a:r>
+              <a:rPr lang="he-IL" dirty="0">
+                <a:cs typeface="Arial"/>
+                <a:ea typeface="Arial"/>
+              </a:rPr>
+              <a:t>אם יש יותר מדי טקסט, הקהל מתחיל לקרוא במקום להקשיב.</a:t>
+            </a:r>
+            <a:endParaRPr lang="he-IL" dirty="0"/>
           </a:p>
         </p:txBody>
       </p:sp>
@@ -867,13 +963,37 @@
           <a:bodyPr/>
           <a:lstStyle/>
           <a:p>
-            <a:r>
-              <a:rPr lang="en-US" dirty="0"/>
-              <a:t>כאן אני מדגיש את ההבדל בין חיפוש תוצאות לבין הסבר לקהל.
-לא צריך להראות את כל מה שעשינו. צריך להראות רק את הדברים שבאמת תומכים בטענה המרכזית.
-כשהשקף נהיה עמוס, הקהל לא יודע לאן להסתכל.</a:t>
-            </a:r>
-            <a:endParaRPr lang="en-US" dirty="0"/>
+            <a:pPr rtl="1" algn="r"/>
+            <a:r>
+              <a:rPr lang="he-IL" dirty="0">
+                <a:cs typeface="Arial"/>
+                <a:ea typeface="Arial"/>
+              </a:rPr>
+              <a:t>כאן אני מדגיש את ההבדל בין חיפוש תוצאות לבין הסבר לקהל.</a:t>
+            </a:r>
+            <a:endParaRPr lang="he-IL" dirty="0"/>
+          </a:p>
+          <a:p>
+            <a:pPr rtl="1" algn="r"/>
+            <a:r>
+              <a:rPr lang="he-IL" dirty="0">
+                <a:cs typeface="Arial"/>
+                <a:ea typeface="Arial"/>
+              </a:rPr>
+              <a:t>לא צריך להראות את כל מה שעשינו. צריך להראות רק את הדברים שבאמת תומכים בטענה המרכזית.</a:t>
+            </a:r>
+            <a:endParaRPr lang="he-IL" dirty="0"/>
+          </a:p>
+          <a:p>
+            <a:pPr rtl="1" algn="r"/>
+            <a:r>
+              <a:rPr lang="he-IL" dirty="0">
+                <a:cs typeface="Arial"/>
+                <a:ea typeface="Arial"/>
+              </a:rPr>
+              <a:t>כשהשקף נהיה עמוס, הקהל לא יודע לאן להסתכל.</a:t>
+            </a:r>
+            <a:endParaRPr lang="he-IL" dirty="0"/>
           </a:p>
         </p:txBody>
       </p:sp>
@@ -957,13 +1077,37 @@
           <a:bodyPr/>
           <a:lstStyle/>
           <a:p>
-            <a:r>
-              <a:rPr lang="en-US" dirty="0"/>
-              <a:t>מעברים טובים שומרים על תנופה.
-אני מסכם בקצרה מה היה קודם, ואז מסמן בבירור לאן עוברים.
-גם השפה וגם הוויזואליה צריכים לעבוד יחד, כדי שהקהל לא יאבד את החוט.</a:t>
-            </a:r>
-            <a:endParaRPr lang="en-US" dirty="0"/>
+            <a:pPr rtl="1" algn="r"/>
+            <a:r>
+              <a:rPr lang="he-IL" dirty="0">
+                <a:cs typeface="Arial"/>
+                <a:ea typeface="Arial"/>
+              </a:rPr>
+              <a:t>מעברים טובים שומרים על תנופה.</a:t>
+            </a:r>
+            <a:endParaRPr lang="he-IL" dirty="0"/>
+          </a:p>
+          <a:p>
+            <a:pPr rtl="1" algn="r"/>
+            <a:r>
+              <a:rPr lang="he-IL" dirty="0">
+                <a:cs typeface="Arial"/>
+                <a:ea typeface="Arial"/>
+              </a:rPr>
+              <a:t>אני מסכם בקצרה מה היה קודם, ואז מסמן בבירור לאן עוברים.</a:t>
+            </a:r>
+            <a:endParaRPr lang="he-IL" dirty="0"/>
+          </a:p>
+          <a:p>
+            <a:pPr rtl="1" algn="r"/>
+            <a:r>
+              <a:rPr lang="he-IL" dirty="0">
+                <a:cs typeface="Arial"/>
+                <a:ea typeface="Arial"/>
+              </a:rPr>
+              <a:t>גם השפה וגם הוויזואליה צריכים לעבוד יחד, כדי שהקהל לא יאבד את החוט.</a:t>
+            </a:r>
+            <a:endParaRPr lang="he-IL" dirty="0"/>
           </a:p>
         </p:txBody>
       </p:sp>
@@ -1047,13 +1191,37 @@
           <a:bodyPr/>
           <a:lstStyle/>
           <a:p>
-            <a:r>
-              <a:rPr lang="en-US" dirty="0"/>
-              <a:t>דימוי טוב עוזר לקהל להבין מהר, אבל חייבים להגיד איפה הוא מפסיק להיות מדויק.
-בנוסף צריך לקשור את התוכן להשלכות אמיתיות: למה זה חשוב, למי זה משנה, ומה יוצא מזה.
-כאן אני עובר מהסבר טכני למשמעות אנושית.</a:t>
-            </a:r>
-            <a:endParaRPr lang="en-US" dirty="0"/>
+            <a:pPr rtl="1" algn="r"/>
+            <a:r>
+              <a:rPr lang="he-IL" dirty="0">
+                <a:cs typeface="Arial"/>
+                <a:ea typeface="Arial"/>
+              </a:rPr>
+              <a:t>דימוי טוב עוזר לקהל להבין מהר, אבל חייבים להגיד איפה הוא מפסיק להיות מדויק.</a:t>
+            </a:r>
+            <a:endParaRPr lang="he-IL" dirty="0"/>
+          </a:p>
+          <a:p>
+            <a:pPr rtl="1" algn="r"/>
+            <a:r>
+              <a:rPr lang="he-IL" dirty="0">
+                <a:cs typeface="Arial"/>
+                <a:ea typeface="Arial"/>
+              </a:rPr>
+              <a:t>בנוסף צריך לקשור את התוכן להשלכות אמיתיות: למה זה חשוב, למי זה משנה, ומה יוצא מזה.</a:t>
+            </a:r>
+            <a:endParaRPr lang="he-IL" dirty="0"/>
+          </a:p>
+          <a:p>
+            <a:pPr rtl="1" algn="r"/>
+            <a:r>
+              <a:rPr lang="he-IL" dirty="0">
+                <a:cs typeface="Arial"/>
+                <a:ea typeface="Arial"/>
+              </a:rPr>
+              <a:t>כאן אני עובר מהסבר טכני למשמעות אנושית.</a:t>
+            </a:r>
+            <a:endParaRPr lang="he-IL" dirty="0"/>
           </a:p>
         </p:txBody>
       </p:sp>
@@ -1137,13 +1305,37 @@
           <a:bodyPr/>
           <a:lstStyle/>
           <a:p>
-            <a:r>
-              <a:rPr lang="en-US" dirty="0"/>
-              <a:t>הסיום צריך לענות על ה-So what.
-אני מסכם בשלושה עקרונות פשוטים: להתחיל חזק, לבנות סיפור, ולהראות למה זה חשוב.
-אם הקהל יכול לספר את הטיעון שלך במשפט אחד, המצגת עבדה.</a:t>
-            </a:r>
-            <a:endParaRPr lang="en-US" dirty="0"/>
+            <a:pPr rtl="1" algn="r"/>
+            <a:r>
+              <a:rPr lang="he-IL" dirty="0">
+                <a:cs typeface="Arial"/>
+                <a:ea typeface="Arial"/>
+              </a:rPr>
+              <a:t>הסיום צריך לענות על ה-So what.</a:t>
+            </a:r>
+            <a:endParaRPr lang="he-IL" dirty="0"/>
+          </a:p>
+          <a:p>
+            <a:pPr rtl="1" algn="r"/>
+            <a:r>
+              <a:rPr lang="he-IL" dirty="0">
+                <a:cs typeface="Arial"/>
+                <a:ea typeface="Arial"/>
+              </a:rPr>
+              <a:t>אני מסכם בשלושה עקרונות פשוטים: להתחיל חזק, לבנות סיפור, ולהראות למה זה חשוב.</a:t>
+            </a:r>
+            <a:endParaRPr lang="he-IL" dirty="0"/>
+          </a:p>
+          <a:p>
+            <a:pPr rtl="1" algn="r"/>
+            <a:r>
+              <a:rPr lang="he-IL" dirty="0">
+                <a:cs typeface="Arial"/>
+                <a:ea typeface="Arial"/>
+              </a:rPr>
+              <a:t>אם הקהל יכול לספר את הטיעון שלך במשפט אחד, המצגת עבדה.</a:t>
+            </a:r>
+            <a:endParaRPr lang="he-IL" dirty="0"/>
           </a:p>
         </p:txBody>
       </p:sp>

</xml_diff>